<commit_message>
Fix WPlat/EPlat: remove incorrect biomass burning attribution
The paper does not attribute WPlat/EPlat aerosol to crop residue
burning. Changed to "peak seasonal aerosol load" per the paper text.

Co-Authored-By: Claude Opus 4.6 <noreply@anthropic.com>
Claude-Session: https://claude.ai/code/session_013ce4PKS59x4i27j5CRjVKQ
</commit_message>
<xml_diff>
--- a/seminar/Hari_ecosystem_productivity_India.pptx
+++ b/seminar/Hari_ecosystem_productivity_India.pptx
@@ -107,7 +107,7 @@
   <p:extLst>
     <p:ext uri="{521415D9-36F7-43E2-AB2F-B90AF26B5E84}">
       <p14:sectionLst xmlns:p14="http://schemas.microsoft.com/office/powerpoint/2010/main">
-        <p14:section name="Evidence" id="{07cdcf92-dcae-e359-fc02-70027caa0214}">
+        <p14:section name="Evidence" id="{2a5ac225-5c08-5a45-699b-c238130c4c4e}">
           <p14:sldIdLst>
             <p14:sldId id="256"/>
           </p14:sldIdLst>
@@ -527,7 +527,7 @@
 Forest canopies are multi-layered and vertically complex. Moderate aerosol scattering sends diffuse light deeper into the canopy, reaching photon-efficient shaded leaves. NPP peaks at AOD 0.38, effect persists to 0.51.
 Croplands have flat, single-layer canopy — no vertical structure for diffuse light to exploit. Diffuse PAR in agro zones rises only up to AOD 0.54, then falls. These zones routinely exceed that threshold — MGP averages 0.57, TGP peaks at 0.91 during monsoon.
 MAXIMUM NEGATIVE EFFECT:
-Western Plateau (WPlat) and Eastern Plateau (EPlat) showed the maximum negative effect, particularly in post-monsoon season. This is because post-monsoon should be peak NPP season (ideal conditions after monsoon rains), but aerosol loading from biomass burning and industrial emissions peaks at the same time, suppressing the most productive window.</a:t>
+Western Plateau (WPlat — MP, Maharashtra) and Eastern Plateau (EPlat — Chhattisgarh, Jharkhand, Orissa) showed the maximum negative effect, particularly in post-monsoon season. Post-monsoon should be peak NPP season (ideal conditions after monsoon rains), but seasonal aerosol load peaks at the same time. Even though WPlat has relatively low mean AOD (0.38), it exceeds the optimal threshold for the plateau's mixed vegetation canopy, suppressing the most productive window.</a:t>
             </a:r>
             <a:endParaRPr lang="en-US" dirty="0"/>
           </a:p>
@@ -2166,7 +2166,7 @@
                   <a:schemeClr val="tx1"/>
                 </a:solidFill>
               </a:rPr>
-              <a:t>Maximum negative effect: Western and Eastern Plateau, post-monsoon season (peak aerosol loading from biomass burning)</a:t>
+              <a:t>Maximum negative effect: Western and Eastern Plateau, post-monsoon season (peak seasonal aerosol load)</a:t>
             </a:r>
             <a:endParaRPr lang="en-US" sz="1300" dirty="0"/>
           </a:p>

</xml_diff>